<commit_message>
Updated paper and slides
Updated paper and slides
</commit_message>
<xml_diff>
--- a/SilentEpidemic.pptx
+++ b/SilentEpidemic.pptx
@@ -5312,21 +5312,10 @@
           <a:bodyPr wrap="square" rtlCol="0" anchor="ctr"/>
           <a:lstStyle/>
           <a:p>
-            <a:pPr marL="0" indent="0">
-              <a:buNone/>
-            </a:pPr>
-            <a:r>
-              <a:rPr lang="en-US" sz="1000" dirty="0">
-                <a:solidFill>
-                  <a:srgbClr val="333333"/>
-                </a:solidFill>
-                <a:latin typeface="Calibri" pitchFamily="34" charset="0"/>
-                <a:ea typeface="Calibri" pitchFamily="34" charset="-122"/>
-                <a:cs typeface="Calibri" pitchFamily="34" charset="-120"/>
-              </a:rPr>
-              <a:t>Raw CDC mortality counts + Census population via tidycensus</a:t>
-            </a:r>
-            <a:endParaRPr lang="en-US" sz="1000" dirty="0"/>
+            <a:r>
+              <a:rPr lang="en-US" sz="1000" dirty="0"/>
+              <a:t>Raw CDC mortality counts + Census population denominators (pre-linked by CDC WONDER)</a:t>
+            </a:r>
           </a:p>
         </p:txBody>
       </p:sp>
@@ -5756,7 +5745,7 @@
                 <a:ea typeface="Calibri" pitchFamily="34" charset="-122"/>
                 <a:cs typeface="Calibri" pitchFamily="34" charset="-120"/>
               </a:rPr>
-              <a:t>All 7,178 records included · 10 billion person-years of exposure</a:t>
+              <a:t>All 7,178 records included ~10 billion person-years of exposure estimated</a:t>
             </a:r>
             <a:endParaRPr lang="en-US" sz="1000" dirty="0"/>
           </a:p>

</xml_diff>